<commit_message>
Expand PPT full-deck themes to ten layout styles and enrich Master API styling.
Add five new built-in themes with distinct layouts, refactor template generation into shared scripts, extend PPT Master with style presets and UI guides, and fix editable export by copying slide rels with XML.

Co-authored-by: Cursor <cursoragent@cursor.com>
</commit_message>
<xml_diff>
--- a/public/ppt-beautify/covers/blue-business.pptx
+++ b/public/ppt-beautify/covers/blue-business.pptx
@@ -938,7 +938,7 @@
           <a:bodyPr wrap="square" rtlCol="0" anchor="ctr"/>
           <a:lstStyle/>
           <a:p>
-            <a:pPr indent="0" marL="0">
+            <a:pPr algn="l" indent="0" marL="0">
               <a:buNone/>
             </a:pPr>
             <a:r>
@@ -950,7 +950,7 @@
                 <a:ea typeface="Microsoft YaHei" pitchFamily="34" charset="-122"/>
                 <a:cs typeface="Microsoft YaHei" pitchFamily="34" charset="-120"/>
               </a:rPr>
-              <a:t>在此填写主标题</a:t>
+              <a:t>CC_COVER_TITLE</a:t>
             </a:r>
             <a:endParaRPr lang="en-US" sz="3200" dirty="0"/>
           </a:p>
@@ -977,7 +977,7 @@
           <a:bodyPr wrap="square" rtlCol="0" anchor="ctr"/>
           <a:lstStyle/>
           <a:p>
-            <a:pPr indent="0" marL="0">
+            <a:pPr algn="l" indent="0" marL="0">
               <a:buNone/>
             </a:pPr>
             <a:r>
@@ -989,7 +989,7 @@
                 <a:ea typeface="Microsoft YaHei" pitchFamily="34" charset="-122"/>
                 <a:cs typeface="Microsoft YaHei" pitchFamily="34" charset="-120"/>
               </a:rPr>
-              <a:t>在此填写副标题</a:t>
+              <a:t>CC_COVER_SUBTITLE</a:t>
             </a:r>
             <a:endParaRPr lang="en-US" sz="1600" dirty="0"/>
           </a:p>
@@ -1028,7 +1028,7 @@
                 <a:ea typeface="Microsoft YaHei" pitchFamily="34" charset="-122"/>
                 <a:cs typeface="Microsoft YaHei" pitchFamily="34" charset="-120"/>
               </a:rPr>
-              <a:t>汇报人</a:t>
+              <a:t>CC_COVER_AUTHOR</a:t>
             </a:r>
             <a:endParaRPr lang="en-US" sz="1200" dirty="0"/>
           </a:p>
@@ -1067,7 +1067,7 @@
                 <a:ea typeface="Microsoft YaHei" pitchFamily="34" charset="-122"/>
                 <a:cs typeface="Microsoft YaHei" pitchFamily="34" charset="-120"/>
               </a:rPr>
-              <a:t>2025.01.01</a:t>
+              <a:t>CC_COVER_DATE</a:t>
             </a:r>
             <a:endParaRPr lang="en-US" sz="1200" dirty="0"/>
           </a:p>

</xml_diff>